<commit_message>
Variables, data types, control structures
Co-authored-by: Copilot <copilot@github.com>
</commit_message>
<xml_diff>
--- a/C Class/docs/Level_1__Lesson_10_Data_Types.pptx
+++ b/C Class/docs/Level_1__Lesson_10_Data_Types.pptx
@@ -312,7 +312,7 @@
           <a:p>
             <a:fld id="{5BCAD085-E8A6-8845-BD4E-CB4CCA059FC4}" type="datetimeFigureOut">
               <a:rPr lang="en-US" smtClean="0"/>
-              <a:t>1/25/2026</a:t>
+              <a:t>4/22/2026</a:t>
             </a:fld>
             <a:endParaRPr lang="en-US"/>
           </a:p>
@@ -480,7 +480,7 @@
           <a:p>
             <a:fld id="{5BCAD085-E8A6-8845-BD4E-CB4CCA059FC4}" type="datetimeFigureOut">
               <a:rPr lang="en-US" smtClean="0"/>
-              <a:t>1/25/2026</a:t>
+              <a:t>4/22/2026</a:t>
             </a:fld>
             <a:endParaRPr lang="en-US"/>
           </a:p>
@@ -658,7 +658,7 @@
           <a:p>
             <a:fld id="{5BCAD085-E8A6-8845-BD4E-CB4CCA059FC4}" type="datetimeFigureOut">
               <a:rPr lang="en-US" smtClean="0"/>
-              <a:t>1/25/2026</a:t>
+              <a:t>4/22/2026</a:t>
             </a:fld>
             <a:endParaRPr lang="en-US"/>
           </a:p>
@@ -826,7 +826,7 @@
           <a:p>
             <a:fld id="{5BCAD085-E8A6-8845-BD4E-CB4CCA059FC4}" type="datetimeFigureOut">
               <a:rPr lang="en-US" smtClean="0"/>
-              <a:t>1/25/2026</a:t>
+              <a:t>4/22/2026</a:t>
             </a:fld>
             <a:endParaRPr lang="en-US"/>
           </a:p>
@@ -1071,7 +1071,7 @@
           <a:p>
             <a:fld id="{5BCAD085-E8A6-8845-BD4E-CB4CCA059FC4}" type="datetimeFigureOut">
               <a:rPr lang="en-US" smtClean="0"/>
-              <a:t>1/25/2026</a:t>
+              <a:t>4/22/2026</a:t>
             </a:fld>
             <a:endParaRPr lang="en-US"/>
           </a:p>
@@ -1356,7 +1356,7 @@
           <a:p>
             <a:fld id="{5BCAD085-E8A6-8845-BD4E-CB4CCA059FC4}" type="datetimeFigureOut">
               <a:rPr lang="en-US" smtClean="0"/>
-              <a:t>1/25/2026</a:t>
+              <a:t>4/22/2026</a:t>
             </a:fld>
             <a:endParaRPr lang="en-US"/>
           </a:p>
@@ -1775,7 +1775,7 @@
           <a:p>
             <a:fld id="{5BCAD085-E8A6-8845-BD4E-CB4CCA059FC4}" type="datetimeFigureOut">
               <a:rPr lang="en-US" smtClean="0"/>
-              <a:t>1/25/2026</a:t>
+              <a:t>4/22/2026</a:t>
             </a:fld>
             <a:endParaRPr lang="en-US"/>
           </a:p>
@@ -1892,7 +1892,7 @@
           <a:p>
             <a:fld id="{5BCAD085-E8A6-8845-BD4E-CB4CCA059FC4}" type="datetimeFigureOut">
               <a:rPr lang="en-US" smtClean="0"/>
-              <a:t>1/25/2026</a:t>
+              <a:t>4/22/2026</a:t>
             </a:fld>
             <a:endParaRPr lang="en-US"/>
           </a:p>
@@ -1987,7 +1987,7 @@
           <a:p>
             <a:fld id="{5BCAD085-E8A6-8845-BD4E-CB4CCA059FC4}" type="datetimeFigureOut">
               <a:rPr lang="en-US" smtClean="0"/>
-              <a:t>1/25/2026</a:t>
+              <a:t>4/22/2026</a:t>
             </a:fld>
             <a:endParaRPr lang="en-US"/>
           </a:p>
@@ -2262,7 +2262,7 @@
           <a:p>
             <a:fld id="{5BCAD085-E8A6-8845-BD4E-CB4CCA059FC4}" type="datetimeFigureOut">
               <a:rPr lang="en-US" smtClean="0"/>
-              <a:t>1/25/2026</a:t>
+              <a:t>4/22/2026</a:t>
             </a:fld>
             <a:endParaRPr lang="en-US"/>
           </a:p>
@@ -2514,7 +2514,7 @@
           <a:p>
             <a:fld id="{5BCAD085-E8A6-8845-BD4E-CB4CCA059FC4}" type="datetimeFigureOut">
               <a:rPr lang="en-US" smtClean="0"/>
-              <a:t>1/25/2026</a:t>
+              <a:t>4/22/2026</a:t>
             </a:fld>
             <a:endParaRPr lang="en-US"/>
           </a:p>
@@ -2725,7 +2725,7 @@
           <a:p>
             <a:fld id="{5BCAD085-E8A6-8845-BD4E-CB4CCA059FC4}" type="datetimeFigureOut">
               <a:rPr lang="en-US" smtClean="0"/>
-              <a:t>1/25/2026</a:t>
+              <a:t>4/22/2026</a:t>
             </a:fld>
             <a:endParaRPr lang="en-US"/>
           </a:p>
@@ -4055,48 +4055,79 @@
         </p:nvSpPr>
         <p:spPr/>
         <p:txBody>
-          <a:bodyPr/>
-          <a:lstStyle/>
-          <a:p>
-            <a:r>
+          <a:bodyPr>
+            <a:normAutofit/>
+          </a:bodyPr>
+          <a:lstStyle/>
+          <a:p>
+            <a:r>
+              <a:rPr dirty="0"/>
               <a:t>int age = 12;</a:t>
             </a:r>
           </a:p>
           <a:p>
             <a:r>
+              <a:rPr dirty="0"/>
               <a:t>float marks = 85.5;</a:t>
             </a:r>
           </a:p>
           <a:p>
             <a:r>
-              <a:t>char grade = 'A';</a:t>
-            </a:r>
-          </a:p>
-          <a:p>
-            <a:endParaRPr/>
-          </a:p>
-          <a:p>
-            <a:r>
-              <a:t>printf("Age: %d\n", age);</a:t>
-            </a:r>
-          </a:p>
-          <a:p>
-            <a:r>
-              <a:t>printf("Marks: %f\n", marks);</a:t>
-            </a:r>
-          </a:p>
-          <a:p>
-            <a:r>
-              <a:t>printf("Grade: %c", grade);</a:t>
-            </a:r>
-          </a:p>
-          <a:p>
-            <a:endParaRPr/>
-          </a:p>
-          <a:p>
-            <a:r>
-              <a:t>Don’t worry about extra zeros for now 🙂</a:t>
-            </a:r>
+              <a:rPr dirty="0"/>
+              <a:t>char grade = </a:t>
+            </a:r>
+            <a:r>
+              <a:rPr lang="en-US" dirty="0"/>
+              <a:t>'</a:t>
+            </a:r>
+            <a:r>
+              <a:rPr dirty="0"/>
+              <a:t>A</a:t>
+            </a:r>
+            <a:r>
+              <a:rPr lang="en-US" dirty="0"/>
+              <a:t>'</a:t>
+            </a:r>
+            <a:r>
+              <a:rPr dirty="0"/>
+              <a:t>;</a:t>
+            </a:r>
+          </a:p>
+          <a:p>
+            <a:endParaRPr dirty="0"/>
+          </a:p>
+          <a:p>
+            <a:r>
+              <a:rPr dirty="0" err="1"/>
+              <a:t>printf</a:t>
+            </a:r>
+            <a:r>
+              <a:rPr dirty="0"/>
+              <a:t>("Age: %d\n", age);</a:t>
+            </a:r>
+          </a:p>
+          <a:p>
+            <a:r>
+              <a:rPr dirty="0" err="1"/>
+              <a:t>printf</a:t>
+            </a:r>
+            <a:r>
+              <a:rPr dirty="0"/>
+              <a:t>("Marks: %f\n", marks);</a:t>
+            </a:r>
+          </a:p>
+          <a:p>
+            <a:r>
+              <a:rPr dirty="0" err="1"/>
+              <a:t>printf</a:t>
+            </a:r>
+            <a:r>
+              <a:rPr dirty="0"/>
+              <a:t>("Grade: %c", grade);</a:t>
+            </a:r>
+          </a:p>
+          <a:p>
+            <a:endParaRPr lang="en-US" dirty="0"/>
           </a:p>
         </p:txBody>
       </p:sp>

</xml_diff>